<commit_message>
docs: fix presentation — no supervisor, unique numbering, reworked conclusions
Co-authored-by: arena-agent <297053741+arena-agent@users.noreply.github.com>
</commit_message>
<xml_diff>
--- a/docs/FEDO_certification_presentation.pptx
+++ b/docs/FEDO_certification_presentation.pptx
@@ -3312,31 +3312,6 @@
                 </a:solidFill>
                 <a:latin typeface="Calibri"/>
               </a:rPr>
-              <a:t>Руководитель:</a:t>
-            </a:r>
-            <a:r>
-              <a:rPr sz="2000" b="0">
-                <a:solidFill>
-                  <a:srgbClr val="FFFFFF"/>
-                </a:solidFill>
-                <a:latin typeface="Calibri"/>
-              </a:rPr>
-              <a:t> Мурашов Ю. Н.</a:t>
-            </a:r>
-          </a:p>
-          <a:p>
-            <a:pPr>
-              <a:spcAft>
-                <a:spcPts val="400"/>
-              </a:spcAft>
-            </a:pPr>
-            <a:r>
-              <a:rPr sz="2000" b="1">
-                <a:solidFill>
-                  <a:srgbClr val="FFFFFF"/>
-                </a:solidFill>
-                <a:latin typeface="Calibri"/>
-              </a:rPr>
               <a:t>Проверил:</a:t>
             </a:r>
             <a:r>
@@ -3560,7 +3535,7 @@
                 </a:solidFill>
                 <a:latin typeface="Calibri"/>
               </a:rPr>
-              <a:t>Вывод:</a:t>
+              <a:t>Итог: что выбрано</a:t>
             </a:r>
           </a:p>
           <a:p>
@@ -3588,7 +3563,7 @@
                 </a:solidFill>
                 <a:latin typeface="Calibri"/>
               </a:rPr>
-              <a:t>Сейчас — </a:t>
+              <a:t>Для старта достаточно </a:t>
             </a:r>
             <a:r>
               <a:rPr sz="1900" b="1">
@@ -3597,7 +3572,7 @@
                 </a:solidFill>
                 <a:latin typeface="Calibri"/>
               </a:rPr>
-              <a:t>декларация соответствия (152-ФЗ)</a:t>
+              <a:t>декларации соответствия (152-ФЗ)</a:t>
             </a:r>
             <a:r>
               <a:rPr sz="1900" b="0">
@@ -3606,7 +3581,7 @@
                 </a:solidFill>
                 <a:latin typeface="Calibri"/>
               </a:rPr>
-              <a:t> + политика ИБ</a:t>
+              <a:t> — обязательная сертификация не нужна</a:t>
             </a:r>
           </a:p>
           <a:p>
@@ -3634,7 +3609,7 @@
                 </a:solidFill>
                 <a:latin typeface="Calibri"/>
               </a:rPr>
-              <a:t>Госзаказ — </a:t>
+              <a:t>Под госзаказ — сертификация </a:t>
             </a:r>
             <a:r>
               <a:rPr sz="1900" b="1">
@@ -3671,7 +3646,7 @@
                 </a:solidFill>
                 <a:latin typeface="Calibri"/>
               </a:rPr>
-              <a:t>Шифрование — </a:t>
+              <a:t>Шифрование — только через готовый сертифицированный модуль (</a:t>
             </a:r>
             <a:r>
               <a:rPr sz="1900" b="1">
@@ -3689,7 +3664,7 @@
                 </a:solidFill>
                 <a:latin typeface="Calibri"/>
               </a:rPr>
-              <a:t> только для криптомодуля (готовое СКЗИ)</a:t>
+              <a:t>, например Крипто ПРО CSP)</a:t>
             </a:r>
           </a:p>
           <a:p>
@@ -3717,7 +3692,7 @@
                 </a:solidFill>
                 <a:latin typeface="Calibri"/>
               </a:rPr>
-              <a:t>Европа — </a:t>
+              <a:t>Для Европы в будущем — </a:t>
             </a:r>
             <a:r>
               <a:rPr sz="1900" b="1">
@@ -4119,7 +4094,7 @@
                 </a:solidFill>
                 <a:latin typeface="Calibri"/>
               </a:rPr>
-              <a:t>§1  Описание проекта</a:t>
+              <a:t>§1.1  Описание проекта</a:t>
             </a:r>
           </a:p>
         </p:txBody>
@@ -4437,7 +4412,7 @@
                 </a:solidFill>
                 <a:latin typeface="Calibri"/>
               </a:rPr>
-              <a:t>§1  Функции безопасности</a:t>
+              <a:t>§1.2  Функции безопасности</a:t>
             </a:r>
           </a:p>
         </p:txBody>
@@ -5313,7 +5288,7 @@
                 </a:solidFill>
                 <a:latin typeface="Calibri"/>
               </a:rPr>
-              <a:t>§3  Анализ схем — Россия</a:t>
+              <a:t>§3.1  Анализ схем — Россия</a:t>
             </a:r>
           </a:p>
         </p:txBody>
@@ -5686,7 +5661,7 @@
                 </a:solidFill>
                 <a:latin typeface="Calibri"/>
               </a:rPr>
-              <a:t>§3  Анализ схем — желательные и международные</a:t>
+              <a:t>§3.2  Анализ схем — желательные и международные</a:t>
             </a:r>
           </a:p>
         </p:txBody>
@@ -7096,7 +7071,7 @@
                 </a:solidFill>
                 <a:latin typeface="Calibri"/>
               </a:rPr>
-              <a:t> на выходе + данные $2олько локально</a:t>
+              <a:t> на выходе + данные только локально</a:t>
             </a:r>
           </a:p>
           <a:p>

</xml_diff>